<commit_message>
Clean up deck wording and document unfiltered outliers
- Deck: replace leftover generation text ("final CSV provided by the user", "supplied CSV", "/mnt/data/..." paths
  and image alt text) with plain descriptions of the data; regenerate the PDF
- Deck: lead the duration comparison with medians and note that the 2020 casual average is inflated by outliers
- Methodology and README: state that negative-duration trips and Divvy test rides (HQ QR) were not removed,
  instead of claiming invalid records were checked
- All figures in the deck, README and Power BI preview were re-checked against data/summary/ (totals, shares,
  peaks and medians match)

Co-Authored-By: Claude Opus 5.5 <noreply@anthropic.com>
Claude-Session: https://claude.ai/code/session_011bAp3mvSL7jnJEAUpxtMYf
</commit_message>
<xml_diff>
--- a/presentation/cyclistic_case_study.pptx
+++ b/presentation/cyclistic_case_study.pptx
@@ -1967,6 +1967,10 @@
             <a:prstDash val="solid"/>
           </a:ln>
         </p:spPr>
+        <p:txBody>
+          <a:bodyPr/>
+          <a:p/>
+        </p:txBody>
       </p:sp>
       <p:sp>
         <p:nvSpPr>
@@ -2124,6 +2128,10 @@
             <a:prstDash val="solid"/>
           </a:ln>
         </p:spPr>
+        <p:txBody>
+          <a:bodyPr/>
+          <a:p/>
+        </p:txBody>
       </p:sp>
       <p:sp>
         <p:nvSpPr>
@@ -2264,6 +2272,10 @@
             <a:prstDash val="solid"/>
           </a:ln>
         </p:spPr>
+        <p:txBody>
+          <a:bodyPr/>
+          <a:p/>
+        </p:txBody>
       </p:sp>
       <p:sp>
         <p:nvSpPr>
@@ -2404,6 +2416,10 @@
             <a:prstDash val="solid"/>
           </a:ln>
         </p:spPr>
+        <p:txBody>
+          <a:bodyPr/>
+          <a:p/>
+        </p:txBody>
       </p:sp>
       <p:sp>
         <p:nvSpPr>
@@ -2544,6 +2560,10 @@
             <a:prstDash val="solid"/>
           </a:ln>
         </p:spPr>
+        <p:txBody>
+          <a:bodyPr/>
+          <a:p/>
+        </p:txBody>
       </p:sp>
       <p:sp>
         <p:nvSpPr>
@@ -2684,10 +2704,14 @@
             <a:prstDash val="solid"/>
           </a:ln>
         </p:spPr>
+        <p:txBody>
+          <a:bodyPr/>
+          <a:p/>
+        </p:txBody>
       </p:sp>
       <p:pic>
         <p:nvPicPr>
-          <p:cNvPr id="23" name="Image 0" descr="/mnt/data/RIDER BEHAVIOR Q1 2019 VS Q1 2020(2).png">    </p:cNvPr>
+          <p:cNvPr id="23" name="Image 0" descr="RIDER BEHAVIOR Q1 2019 VS Q1 2020(2)">    </p:cNvPr>
           <p:cNvPicPr>
             <a:picLocks noChangeAspect="1"/>
           </p:cNvPicPr>
@@ -2829,6 +2853,10 @@
             <a:prstDash val="solid"/>
           </a:ln>
         </p:spPr>
+        <p:txBody>
+          <a:bodyPr/>
+          <a:p/>
+        </p:txBody>
       </p:sp>
       <p:sp>
         <p:nvSpPr>
@@ -2899,7 +2927,7 @@
                   <a:srgbClr val="DCE8F3"/>
                 </a:solidFill>
               </a:rPr>
-              <a:t>Final Tableau dashboard provided by the user</a:t>
+              <a:t>Tableau dashboard</a:t>
             </a:r>
             <a:endParaRPr lang="en-US" sz="750" dirty="0"/>
           </a:p>
@@ -3006,10 +3034,14 @@
             <a:prstDash val="solid"/>
           </a:ln>
         </p:spPr>
+        <p:txBody>
+          <a:bodyPr/>
+          <a:p/>
+        </p:txBody>
       </p:sp>
       <p:pic>
         <p:nvPicPr>
-          <p:cNvPr id="8" name="Image 0" descr="/mnt/data/RIDER BEHAVIOR Q1 2019 VS Q1 2020(2).png">    </p:cNvPr>
+          <p:cNvPr id="8" name="Image 0" descr="RIDER BEHAVIOR Q1 2019 VS Q1 2020(2)">    </p:cNvPr>
           <p:cNvPicPr>
             <a:picLocks noChangeAspect="1"/>
           </p:cNvPicPr>
@@ -3091,6 +3123,10 @@
             <a:prstDash val="solid"/>
           </a:ln>
         </p:spPr>
+        <p:txBody>
+          <a:bodyPr/>
+          <a:p/>
+        </p:txBody>
       </p:sp>
       <p:sp>
         <p:nvSpPr>
@@ -3122,7 +3158,7 @@
                   <a:srgbClr val="6B7280"/>
                 </a:solidFill>
               </a:rPr>
-              <a:t>Cyclistic Bike-Share Analysis • Q1 2019 vs Q1 2020 • Based on final CSV provided</a:t>
+              <a:t>Cyclistic Bike-Share Analysis • Q1 2019 vs Q1 2020 • Divvy public trip data</a:t>
             </a:r>
             <a:endParaRPr lang="en-US" sz="650" dirty="0"/>
           </a:p>
@@ -3213,6 +3249,10 @@
             <a:prstDash val="solid"/>
           </a:ln>
         </p:spPr>
+        <p:txBody>
+          <a:bodyPr/>
+          <a:p/>
+        </p:txBody>
       </p:sp>
       <p:sp>
         <p:nvSpPr>
@@ -3390,6 +3430,10 @@
             <a:prstDash val="solid"/>
           </a:ln>
         </p:spPr>
+        <p:txBody>
+          <a:bodyPr/>
+          <a:p/>
+        </p:txBody>
       </p:sp>
       <p:sp>
         <p:nvSpPr>
@@ -3415,6 +3459,10 @@
             <a:prstDash val="solid"/>
           </a:ln>
         </p:spPr>
+        <p:txBody>
+          <a:bodyPr/>
+          <a:p/>
+        </p:txBody>
       </p:sp>
       <p:sp>
         <p:nvSpPr>
@@ -3550,6 +3598,10 @@
             <a:prstDash val="solid"/>
           </a:ln>
         </p:spPr>
+        <p:txBody>
+          <a:bodyPr/>
+          <a:p/>
+        </p:txBody>
       </p:sp>
       <p:sp>
         <p:nvSpPr>
@@ -3653,6 +3705,10 @@
             <a:prstDash val="solid"/>
           </a:ln>
         </p:spPr>
+        <p:txBody>
+          <a:bodyPr/>
+          <a:p/>
+        </p:txBody>
       </p:sp>
       <p:sp>
         <p:nvSpPr>
@@ -3678,6 +3734,10 @@
             <a:prstDash val="solid"/>
           </a:ln>
         </p:spPr>
+        <p:txBody>
+          <a:bodyPr/>
+          <a:p/>
+        </p:txBody>
       </p:sp>
       <p:sp>
         <p:nvSpPr>
@@ -3813,6 +3873,10 @@
             <a:prstDash val="solid"/>
           </a:ln>
         </p:spPr>
+        <p:txBody>
+          <a:bodyPr/>
+          <a:p/>
+        </p:txBody>
       </p:sp>
       <p:sp>
         <p:nvSpPr>
@@ -3916,6 +3980,10 @@
             <a:prstDash val="solid"/>
           </a:ln>
         </p:spPr>
+        <p:txBody>
+          <a:bodyPr/>
+          <a:p/>
+        </p:txBody>
       </p:sp>
       <p:sp>
         <p:nvSpPr>
@@ -3941,6 +4009,10 @@
             <a:prstDash val="solid"/>
           </a:ln>
         </p:spPr>
+        <p:txBody>
+          <a:bodyPr/>
+          <a:p/>
+        </p:txBody>
       </p:sp>
       <p:sp>
         <p:nvSpPr>
@@ -4076,6 +4148,10 @@
             <a:prstDash val="solid"/>
           </a:ln>
         </p:spPr>
+        <p:txBody>
+          <a:bodyPr/>
+          <a:p/>
+        </p:txBody>
       </p:sp>
       <p:sp>
         <p:nvSpPr>
@@ -4177,6 +4253,10 @@
             <a:prstDash val="solid"/>
           </a:ln>
         </p:spPr>
+        <p:txBody>
+          <a:bodyPr/>
+          <a:p/>
+        </p:txBody>
       </p:sp>
       <p:sp>
         <p:nvSpPr>
@@ -4208,7 +4288,7 @@
                   <a:srgbClr val="6B7280"/>
                 </a:solidFill>
               </a:rPr>
-              <a:t>Cyclistic Bike-Share Analysis • Q1 2019 vs Q1 2020 • Based on final CSV provided</a:t>
+              <a:t>Cyclistic Bike-Share Analysis • Q1 2019 vs Q1 2020 • Divvy public trip data</a:t>
             </a:r>
             <a:endParaRPr lang="en-US" sz="650" dirty="0"/>
           </a:p>
@@ -4299,6 +4379,10 @@
             <a:prstDash val="solid"/>
           </a:ln>
         </p:spPr>
+        <p:txBody>
+          <a:bodyPr/>
+          <a:p/>
+        </p:txBody>
       </p:sp>
       <p:sp>
         <p:nvSpPr>
@@ -4476,6 +4560,10 @@
             <a:prstDash val="solid"/>
           </a:ln>
         </p:spPr>
+        <p:txBody>
+          <a:bodyPr/>
+          <a:p/>
+        </p:txBody>
       </p:sp>
       <p:sp>
         <p:nvSpPr>
@@ -4537,6 +4625,10 @@
             <a:prstDash val="solid"/>
           </a:ln>
         </p:spPr>
+        <p:txBody>
+          <a:bodyPr/>
+          <a:p/>
+        </p:txBody>
       </p:sp>
       <p:sp>
         <p:nvSpPr>
@@ -4600,6 +4692,10 @@
             <a:prstDash val="solid"/>
           </a:ln>
         </p:spPr>
+        <p:txBody>
+          <a:bodyPr/>
+          <a:p/>
+        </p:txBody>
       </p:sp>
       <p:sp>
         <p:nvSpPr>
@@ -4663,6 +4759,10 @@
             <a:prstDash val="solid"/>
           </a:ln>
         </p:spPr>
+        <p:txBody>
+          <a:bodyPr/>
+          <a:p/>
+        </p:txBody>
       </p:sp>
       <p:sp>
         <p:nvSpPr>
@@ -4726,6 +4826,10 @@
             <a:prstDash val="solid"/>
           </a:ln>
         </p:spPr>
+        <p:txBody>
+          <a:bodyPr/>
+          <a:p/>
+        </p:txBody>
       </p:sp>
       <p:sp>
         <p:nvSpPr>
@@ -4789,6 +4893,10 @@
             <a:prstDash val="solid"/>
           </a:ln>
         </p:spPr>
+        <p:txBody>
+          <a:bodyPr/>
+          <a:p/>
+        </p:txBody>
       </p:sp>
       <p:sp>
         <p:nvSpPr>
@@ -4854,6 +4962,10 @@
             <a:prstDash val="solid"/>
           </a:ln>
         </p:spPr>
+        <p:txBody>
+          <a:bodyPr/>
+          <a:p/>
+        </p:txBody>
       </p:sp>
       <p:sp>
         <p:nvSpPr>
@@ -4915,6 +5027,10 @@
             <a:prstDash val="solid"/>
           </a:ln>
         </p:spPr>
+        <p:txBody>
+          <a:bodyPr/>
+          <a:p/>
+        </p:txBody>
       </p:sp>
       <p:sp>
         <p:nvSpPr>
@@ -4978,6 +5094,10 @@
             <a:prstDash val="solid"/>
           </a:ln>
         </p:spPr>
+        <p:txBody>
+          <a:bodyPr/>
+          <a:p/>
+        </p:txBody>
       </p:sp>
       <p:sp>
         <p:nvSpPr>
@@ -5041,6 +5161,10 @@
             <a:prstDash val="solid"/>
           </a:ln>
         </p:spPr>
+        <p:txBody>
+          <a:bodyPr/>
+          <a:p/>
+        </p:txBody>
       </p:sp>
       <p:sp>
         <p:nvSpPr>
@@ -5104,6 +5228,10 @@
             <a:prstDash val="solid"/>
           </a:ln>
         </p:spPr>
+        <p:txBody>
+          <a:bodyPr/>
+          <a:p/>
+        </p:txBody>
       </p:sp>
       <p:sp>
         <p:nvSpPr>
@@ -5167,6 +5295,10 @@
             <a:prstDash val="solid"/>
           </a:ln>
         </p:spPr>
+        <p:txBody>
+          <a:bodyPr/>
+          <a:p/>
+        </p:txBody>
       </p:sp>
       <p:sp>
         <p:nvSpPr>
@@ -5232,6 +5364,10 @@
             <a:prstDash val="solid"/>
           </a:ln>
         </p:spPr>
+        <p:txBody>
+          <a:bodyPr/>
+          <a:p/>
+        </p:txBody>
       </p:sp>
       <p:sp>
         <p:nvSpPr>
@@ -5295,6 +5431,10 @@
             <a:prstDash val="solid"/>
           </a:ln>
         </p:spPr>
+        <p:txBody>
+          <a:bodyPr/>
+          <a:p/>
+        </p:txBody>
       </p:sp>
       <p:sp>
         <p:nvSpPr>
@@ -5326,7 +5466,7 @@
                   <a:srgbClr val="6B7280"/>
                 </a:solidFill>
               </a:rPr>
-              <a:t>Cyclistic Bike-Share Analysis • Q1 2019 vs Q1 2020 • Based on final CSV provided</a:t>
+              <a:t>Cyclistic Bike-Share Analysis • Q1 2019 vs Q1 2020 • Divvy public trip data</a:t>
             </a:r>
             <a:endParaRPr lang="en-US" sz="650" dirty="0"/>
           </a:p>
@@ -5417,6 +5557,10 @@
             <a:prstDash val="solid"/>
           </a:ln>
         </p:spPr>
+        <p:txBody>
+          <a:bodyPr/>
+          <a:p/>
+        </p:txBody>
       </p:sp>
       <p:sp>
         <p:nvSpPr>
@@ -5487,7 +5631,7 @@
                   <a:srgbClr val="DCE8F3"/>
                 </a:solidFill>
               </a:rPr>
-              <a:t>Source metrics computed directly from the supplied CSV</a:t>
+              <a:t>Metrics computed from the combined trip dataset</a:t>
             </a:r>
             <a:endParaRPr lang="en-US" sz="750" dirty="0"/>
           </a:p>
@@ -5592,6 +5736,10 @@
             <a:prstDash val="solid"/>
           </a:ln>
         </p:spPr>
+        <p:txBody>
+          <a:bodyPr/>
+          <a:p/>
+        </p:txBody>
       </p:sp>
       <p:sp>
         <p:nvSpPr>
@@ -5693,6 +5841,10 @@
             <a:prstDash val="solid"/>
           </a:ln>
         </p:spPr>
+        <p:txBody>
+          <a:bodyPr/>
+          <a:p/>
+        </p:txBody>
       </p:sp>
       <p:sp>
         <p:nvSpPr>
@@ -5794,6 +5946,10 @@
             <a:prstDash val="solid"/>
           </a:ln>
         </p:spPr>
+        <p:txBody>
+          <a:bodyPr/>
+          <a:p/>
+        </p:txBody>
       </p:sp>
       <p:sp>
         <p:nvSpPr>
@@ -5895,6 +6051,10 @@
             <a:prstDash val="solid"/>
           </a:ln>
         </p:spPr>
+        <p:txBody>
+          <a:bodyPr/>
+          <a:p/>
+        </p:txBody>
       </p:sp>
       <p:sp>
         <p:nvSpPr>
@@ -5996,6 +6156,10 @@
             <a:prstDash val="solid"/>
           </a:ln>
         </p:spPr>
+        <p:txBody>
+          <a:bodyPr/>
+          <a:p/>
+        </p:txBody>
       </p:sp>
       <p:sp>
         <p:nvSpPr>
@@ -6097,6 +6261,10 @@
             <a:prstDash val="solid"/>
           </a:ln>
         </p:spPr>
+        <p:txBody>
+          <a:bodyPr/>
+          <a:p/>
+        </p:txBody>
       </p:sp>
       <p:sp>
         <p:nvSpPr>
@@ -6198,6 +6366,10 @@
             <a:prstDash val="solid"/>
           </a:ln>
         </p:spPr>
+        <p:txBody>
+          <a:bodyPr/>
+          <a:p/>
+        </p:txBody>
       </p:sp>
       <p:sp>
         <p:nvSpPr>
@@ -6299,6 +6471,10 @@
             <a:prstDash val="solid"/>
           </a:ln>
         </p:spPr>
+        <p:txBody>
+          <a:bodyPr/>
+          <a:p/>
+        </p:txBody>
       </p:sp>
       <p:sp>
         <p:nvSpPr>
@@ -6400,6 +6576,10 @@
             <a:prstDash val="solid"/>
           </a:ln>
         </p:spPr>
+        <p:txBody>
+          <a:bodyPr/>
+          <a:p/>
+        </p:txBody>
       </p:sp>
       <p:sp>
         <p:nvSpPr>
@@ -6501,6 +6681,10 @@
             <a:prstDash val="solid"/>
           </a:ln>
         </p:spPr>
+        <p:txBody>
+          <a:bodyPr/>
+          <a:p/>
+        </p:txBody>
       </p:sp>
       <p:sp>
         <p:nvSpPr>
@@ -6608,7 +6792,7 @@
                   <a:srgbClr val="6B7280"/>
                 </a:solidFill>
               </a:rPr>
-              <a:t>Data source for metrics: /mnt/data/Trip_Q1_2019_vs_Trip_Q1_2020(1).csv. All calculations use the values in this file as supplied.</a:t>
+              <a:t>Data source: Trip_Q1_2019_vs_Trip_Q1_2020.csv, built in notebooks/cyclistic_bike_share_analysis.ipynb. Aggregates are in data/summary/.</a:t>
             </a:r>
             <a:endParaRPr lang="en-US" sz="750" dirty="0"/>
           </a:p>
@@ -6638,6 +6822,10 @@
             <a:prstDash val="solid"/>
           </a:ln>
         </p:spPr>
+        <p:txBody>
+          <a:bodyPr/>
+          <a:p/>
+        </p:txBody>
       </p:sp>
       <p:sp>
         <p:nvSpPr>
@@ -6669,7 +6857,7 @@
                   <a:srgbClr val="6B7280"/>
                 </a:solidFill>
               </a:rPr>
-              <a:t>Cyclistic Bike-Share Analysis • Q1 2019 vs Q1 2020 • Based on final CSV provided</a:t>
+              <a:t>Cyclistic Bike-Share Analysis • Q1 2019 vs Q1 2020 • Divvy public trip data</a:t>
             </a:r>
             <a:endParaRPr lang="en-US" sz="650" dirty="0"/>
           </a:p>
@@ -6760,6 +6948,10 @@
             <a:prstDash val="solid"/>
           </a:ln>
         </p:spPr>
+        <p:txBody>
+          <a:bodyPr/>
+          <a:p/>
+        </p:txBody>
       </p:sp>
       <p:sp>
         <p:nvSpPr>
@@ -6830,7 +7022,7 @@
                   <a:srgbClr val="DCE8F3"/>
                 </a:solidFill>
               </a:rPr>
-              <a:t>The deck uses the final CSV provided by the user; no additional filtering was applied after import.</a:t>
+              <a:t>Divvy public trip data, Q1 2019 and Q1 2020, combined into one dataset of 791,955 rides.</a:t>
             </a:r>
             <a:endParaRPr lang="en-US" sz="750" dirty="0"/>
           </a:p>
@@ -6937,6 +7129,10 @@
             <a:prstDash val="solid"/>
           </a:ln>
         </p:spPr>
+        <p:txBody>
+          <a:bodyPr/>
+          <a:p/>
+        </p:txBody>
       </p:sp>
       <p:sp>
         <p:nvSpPr>
@@ -7077,6 +7273,10 @@
             <a:prstDash val="solid"/>
           </a:ln>
         </p:spPr>
+        <p:txBody>
+          <a:bodyPr/>
+          <a:p/>
+        </p:txBody>
       </p:sp>
       <p:sp>
         <p:nvSpPr>
@@ -7217,6 +7417,10 @@
             <a:prstDash val="solid"/>
           </a:ln>
         </p:spPr>
+        <p:txBody>
+          <a:bodyPr/>
+          <a:p/>
+        </p:txBody>
       </p:sp>
       <p:sp>
         <p:nvSpPr>
@@ -7357,6 +7561,10 @@
             <a:prstDash val="solid"/>
           </a:ln>
         </p:spPr>
+        <p:txBody>
+          <a:bodyPr/>
+          <a:p/>
+        </p:txBody>
       </p:sp>
       <p:sp>
         <p:nvSpPr>
@@ -7497,6 +7705,10 @@
             <a:prstDash val="solid"/>
           </a:ln>
         </p:spPr>
+        <p:txBody>
+          <a:bodyPr/>
+          <a:p/>
+        </p:txBody>
       </p:sp>
       <p:sp>
         <p:nvSpPr>
@@ -7558,6 +7770,10 @@
             <a:prstDash val="solid"/>
           </a:ln>
         </p:spPr>
+        <p:txBody>
+          <a:bodyPr/>
+          <a:p/>
+        </p:txBody>
       </p:sp>
       <p:sp>
         <p:nvSpPr>
@@ -7632,6 +7848,10 @@
             <a:prstDash val="solid"/>
           </a:ln>
         </p:spPr>
+        <p:txBody>
+          <a:bodyPr/>
+          <a:p/>
+        </p:txBody>
       </p:sp>
       <p:sp>
         <p:nvSpPr>
@@ -7665,7 +7885,7 @@
                   <a:srgbClr val="222222"/>
                 </a:solidFill>
               </a:rPr>
-              <a:t>Casual riders take longer rides</a:t>
+              <a:t>Casual riders take longer rides: their median ride is about 2.5 times a member's (21–23 vs 8–9 minutes).</a:t>
             </a:r>
             <a:pPr indent="0" marL="0">
               <a:buNone/>
@@ -7676,7 +7896,7 @@
                   <a:srgbClr val="222222"/>
                 </a:solidFill>
               </a:rPr>
-              <a:t>: average duration is materially higher for casual riders.</a:t>
+              <a:t/>
             </a:r>
             <a:endParaRPr lang="en-US" sz="1050" dirty="0"/>
           </a:p>
@@ -7706,6 +7926,10 @@
             <a:prstDash val="solid"/>
           </a:ln>
         </p:spPr>
+        <p:txBody>
+          <a:bodyPr/>
+          <a:p/>
+        </p:txBody>
       </p:sp>
       <p:sp>
         <p:nvSpPr>
@@ -7780,6 +8004,10 @@
             <a:prstDash val="solid"/>
           </a:ln>
         </p:spPr>
+        <p:txBody>
+          <a:bodyPr/>
+          <a:p/>
+        </p:txBody>
       </p:sp>
       <p:sp>
         <p:nvSpPr>
@@ -7856,10 +8084,14 @@
             <a:prstDash val="solid"/>
           </a:ln>
         </p:spPr>
+        <p:txBody>
+          <a:bodyPr/>
+          <a:p/>
+        </p:txBody>
       </p:sp>
       <p:pic>
         <p:nvPicPr>
-          <p:cNvPr id="34" name="Image 0" descr="/mnt/data/cyclistic_user_assets/rider_mix_donut.png">    </p:cNvPr>
+          <p:cNvPr id="34" name="Image 0" descr="rider_mix_donut">    </p:cNvPr>
           <p:cNvPicPr>
             <a:picLocks noChangeAspect="1"/>
           </p:cNvPicPr>
@@ -7907,10 +8139,14 @@
             <a:prstDash val="solid"/>
           </a:ln>
         </p:spPr>
+        <p:txBody>
+          <a:bodyPr/>
+          <a:p/>
+        </p:txBody>
       </p:sp>
       <p:pic>
         <p:nvPicPr>
-          <p:cNvPr id="36" name="Image 1" descr="/mnt/data/cyclistic_user_assets/ride_count_by_year_type.png">    </p:cNvPr>
+          <p:cNvPr id="36" name="Image 1" descr="ride_count_by_year_type">    </p:cNvPr>
           <p:cNvPicPr>
             <a:picLocks noChangeAspect="1"/>
           </p:cNvPicPr>
@@ -7956,6 +8192,10 @@
             <a:prstDash val="solid"/>
           </a:ln>
         </p:spPr>
+        <p:txBody>
+          <a:bodyPr/>
+          <a:p/>
+        </p:txBody>
       </p:sp>
       <p:sp>
         <p:nvSpPr>
@@ -7987,7 +8227,7 @@
                   <a:srgbClr val="6B7280"/>
                 </a:solidFill>
               </a:rPr>
-              <a:t>Cyclistic Bike-Share Analysis • Q1 2019 vs Q1 2020 • Based on final CSV provided</a:t>
+              <a:t>Cyclistic Bike-Share Analysis • Q1 2019 vs Q1 2020 • Divvy public trip data</a:t>
             </a:r>
             <a:endParaRPr lang="en-US" sz="650" dirty="0"/>
           </a:p>
@@ -8078,6 +8318,10 @@
             <a:prstDash val="solid"/>
           </a:ln>
         </p:spPr>
+        <p:txBody>
+          <a:bodyPr/>
+          <a:p/>
+        </p:txBody>
       </p:sp>
       <p:sp>
         <p:nvSpPr>
@@ -8255,6 +8499,10 @@
             <a:prstDash val="solid"/>
           </a:ln>
         </p:spPr>
+        <p:txBody>
+          <a:bodyPr/>
+          <a:p/>
+        </p:txBody>
       </p:sp>
       <p:sp>
         <p:nvSpPr>
@@ -8392,6 +8640,10 @@
             <a:prstDash val="solid"/>
           </a:ln>
         </p:spPr>
+        <p:txBody>
+          <a:bodyPr/>
+          <a:p/>
+        </p:txBody>
       </p:sp>
       <p:sp>
         <p:nvSpPr>
@@ -8453,6 +8705,10 @@
             <a:prstDash val="solid"/>
           </a:ln>
         </p:spPr>
+        <p:txBody>
+          <a:bodyPr/>
+          <a:p/>
+        </p:txBody>
       </p:sp>
       <p:sp>
         <p:nvSpPr>
@@ -8527,6 +8783,10 @@
             <a:prstDash val="solid"/>
           </a:ln>
         </p:spPr>
+        <p:txBody>
+          <a:bodyPr/>
+          <a:p/>
+        </p:txBody>
       </p:sp>
       <p:sp>
         <p:nvSpPr>
@@ -8601,6 +8861,10 @@
             <a:prstDash val="solid"/>
           </a:ln>
         </p:spPr>
+        <p:txBody>
+          <a:bodyPr/>
+          <a:p/>
+        </p:txBody>
       </p:sp>
       <p:sp>
         <p:nvSpPr>
@@ -8713,6 +8977,10 @@
             <a:prstDash val="solid"/>
           </a:ln>
         </p:spPr>
+        <p:txBody>
+          <a:bodyPr/>
+          <a:p/>
+        </p:txBody>
       </p:sp>
       <p:sp>
         <p:nvSpPr>
@@ -8738,6 +9006,10 @@
             <a:prstDash val="solid"/>
           </a:ln>
         </p:spPr>
+        <p:txBody>
+          <a:bodyPr/>
+          <a:p/>
+        </p:txBody>
       </p:sp>
       <p:sp>
         <p:nvSpPr>
@@ -8837,6 +9109,10 @@
             <a:prstDash val="solid"/>
           </a:ln>
         </p:spPr>
+        <p:txBody>
+          <a:bodyPr/>
+          <a:p/>
+        </p:txBody>
       </p:sp>
       <p:sp>
         <p:nvSpPr>
@@ -8862,6 +9138,10 @@
             <a:prstDash val="solid"/>
           </a:ln>
         </p:spPr>
+        <p:txBody>
+          <a:bodyPr/>
+          <a:p/>
+        </p:txBody>
       </p:sp>
       <p:sp>
         <p:nvSpPr>
@@ -8961,6 +9241,10 @@
             <a:prstDash val="solid"/>
           </a:ln>
         </p:spPr>
+        <p:txBody>
+          <a:bodyPr/>
+          <a:p/>
+        </p:txBody>
       </p:sp>
       <p:sp>
         <p:nvSpPr>
@@ -8986,6 +9270,10 @@
             <a:prstDash val="solid"/>
           </a:ln>
         </p:spPr>
+        <p:txBody>
+          <a:bodyPr/>
+          <a:p/>
+        </p:txBody>
       </p:sp>
       <p:sp>
         <p:nvSpPr>
@@ -9085,6 +9373,10 @@
             <a:prstDash val="solid"/>
           </a:ln>
         </p:spPr>
+        <p:txBody>
+          <a:bodyPr/>
+          <a:p/>
+        </p:txBody>
       </p:sp>
       <p:sp>
         <p:nvSpPr>
@@ -9110,6 +9402,10 @@
             <a:prstDash val="solid"/>
           </a:ln>
         </p:spPr>
+        <p:txBody>
+          <a:bodyPr/>
+          <a:p/>
+        </p:txBody>
       </p:sp>
       <p:sp>
         <p:nvSpPr>
@@ -9209,6 +9505,10 @@
             <a:prstDash val="solid"/>
           </a:ln>
         </p:spPr>
+        <p:txBody>
+          <a:bodyPr/>
+          <a:p/>
+        </p:txBody>
       </p:sp>
       <p:sp>
         <p:nvSpPr>
@@ -9234,6 +9534,10 @@
             <a:prstDash val="solid"/>
           </a:ln>
         </p:spPr>
+        <p:txBody>
+          <a:bodyPr/>
+          <a:p/>
+        </p:txBody>
       </p:sp>
       <p:sp>
         <p:nvSpPr>
@@ -9333,6 +9637,10 @@
             <a:prstDash val="solid"/>
           </a:ln>
         </p:spPr>
+        <p:txBody>
+          <a:bodyPr/>
+          <a:p/>
+        </p:txBody>
       </p:sp>
       <p:sp>
         <p:nvSpPr>
@@ -9358,6 +9666,10 @@
             <a:prstDash val="solid"/>
           </a:ln>
         </p:spPr>
+        <p:txBody>
+          <a:bodyPr/>
+          <a:p/>
+        </p:txBody>
       </p:sp>
       <p:sp>
         <p:nvSpPr>
@@ -9491,6 +9803,10 @@
             <a:prstDash val="solid"/>
           </a:ln>
         </p:spPr>
+        <p:txBody>
+          <a:bodyPr/>
+          <a:p/>
+        </p:txBody>
       </p:sp>
       <p:sp>
         <p:nvSpPr>
@@ -9522,7 +9838,7 @@
                   <a:srgbClr val="6B7280"/>
                 </a:solidFill>
               </a:rPr>
-              <a:t>Cyclistic Bike-Share Analysis • Q1 2019 vs Q1 2020 • Based on final CSV provided</a:t>
+              <a:t>Cyclistic Bike-Share Analysis • Q1 2019 vs Q1 2020 • Divvy public trip data</a:t>
             </a:r>
             <a:endParaRPr lang="en-US" sz="650" dirty="0"/>
           </a:p>
@@ -9613,6 +9929,10 @@
             <a:prstDash val="solid"/>
           </a:ln>
         </p:spPr>
+        <p:txBody>
+          <a:bodyPr/>
+          <a:p/>
+        </p:txBody>
       </p:sp>
       <p:sp>
         <p:nvSpPr>
@@ -9758,7 +10078,7 @@
                   <a:srgbClr val="6B7280"/>
                 </a:solidFill>
               </a:rPr>
-              <a:t>The analysis is based on the final CSV supplied for this case study and visualized in Tableau.</a:t>
+              <a:t>The Q1 2019 and Q1 2020 trip files were combined into one dataset and visualized in Tableau and Power BI.</a:t>
             </a:r>
             <a:endParaRPr lang="en-US" sz="950" dirty="0"/>
           </a:p>
@@ -9790,6 +10110,10 @@
             <a:prstDash val="solid"/>
           </a:ln>
         </p:spPr>
+        <p:txBody>
+          <a:bodyPr/>
+          <a:p/>
+        </p:txBody>
       </p:sp>
       <p:sp>
         <p:nvSpPr>
@@ -9930,6 +10254,10 @@
             <a:prstDash val="solid"/>
           </a:ln>
         </p:spPr>
+        <p:txBody>
+          <a:bodyPr/>
+          <a:p/>
+        </p:txBody>
       </p:sp>
       <p:sp>
         <p:nvSpPr>
@@ -10070,6 +10398,10 @@
             <a:prstDash val="solid"/>
           </a:ln>
         </p:spPr>
+        <p:txBody>
+          <a:bodyPr/>
+          <a:p/>
+        </p:txBody>
       </p:sp>
       <p:sp>
         <p:nvSpPr>
@@ -10210,6 +10542,10 @@
             <a:prstDash val="solid"/>
           </a:ln>
         </p:spPr>
+        <p:txBody>
+          <a:bodyPr/>
+          <a:p/>
+        </p:txBody>
       </p:sp>
       <p:sp>
         <p:nvSpPr>
@@ -10350,6 +10686,10 @@
             <a:prstDash val="solid"/>
           </a:ln>
         </p:spPr>
+        <p:txBody>
+          <a:bodyPr/>
+          <a:p/>
+        </p:txBody>
       </p:sp>
       <p:sp>
         <p:nvSpPr>
@@ -10411,6 +10751,10 @@
             <a:prstDash val="solid"/>
           </a:ln>
         </p:spPr>
+        <p:txBody>
+          <a:bodyPr/>
+          <a:p/>
+        </p:txBody>
       </p:sp>
       <p:sp>
         <p:nvSpPr>
@@ -10474,6 +10818,10 @@
             <a:prstDash val="solid"/>
           </a:ln>
         </p:spPr>
+        <p:txBody>
+          <a:bodyPr/>
+          <a:p/>
+        </p:txBody>
       </p:sp>
       <p:sp>
         <p:nvSpPr>
@@ -10537,6 +10885,10 @@
             <a:prstDash val="solid"/>
           </a:ln>
         </p:spPr>
+        <p:txBody>
+          <a:bodyPr/>
+          <a:p/>
+        </p:txBody>
       </p:sp>
       <p:sp>
         <p:nvSpPr>
@@ -10600,6 +10952,10 @@
             <a:prstDash val="solid"/>
           </a:ln>
         </p:spPr>
+        <p:txBody>
+          <a:bodyPr/>
+          <a:p/>
+        </p:txBody>
       </p:sp>
       <p:sp>
         <p:nvSpPr>
@@ -10701,6 +11057,10 @@
             <a:prstDash val="solid"/>
           </a:ln>
         </p:spPr>
+        <p:txBody>
+          <a:bodyPr/>
+          <a:p/>
+        </p:txBody>
       </p:sp>
       <p:sp>
         <p:nvSpPr>
@@ -10762,6 +11122,10 @@
             <a:prstDash val="solid"/>
           </a:ln>
         </p:spPr>
+        <p:txBody>
+          <a:bodyPr/>
+          <a:p/>
+        </p:txBody>
       </p:sp>
       <p:sp>
         <p:nvSpPr>
@@ -10825,6 +11189,10 @@
             <a:prstDash val="solid"/>
           </a:ln>
         </p:spPr>
+        <p:txBody>
+          <a:bodyPr/>
+          <a:p/>
+        </p:txBody>
       </p:sp>
       <p:sp>
         <p:nvSpPr>
@@ -10858,7 +11226,7 @@
                   <a:srgbClr val="222222"/>
                 </a:solidFill>
               </a:rPr>
-              <a:t>The deck uses the supplied final CSV as the analysis dataset.</a:t>
+              <a:t>Ride length was calculated in Google Sheets before the files were combined in Python.</a:t>
             </a:r>
             <a:endParaRPr lang="en-US" sz="1030" dirty="0"/>
           </a:p>
@@ -10888,6 +11256,10 @@
             <a:prstDash val="solid"/>
           </a:ln>
         </p:spPr>
+        <p:txBody>
+          <a:bodyPr/>
+          <a:p/>
+        </p:txBody>
       </p:sp>
       <p:sp>
         <p:nvSpPr>
@@ -10921,7 +11293,7 @@
                   <a:srgbClr val="222222"/>
                 </a:solidFill>
               </a:rPr>
-              <a:t>No additional filtering or recalculation is applied after import into this deck.</a:t>
+              <a:t>No filter for negative durations or Divvy test rides is applied, so averages include outliers; medians are used for comparisons.</a:t>
             </a:r>
             <a:endParaRPr lang="en-US" sz="1030" dirty="0"/>
           </a:p>
@@ -10951,6 +11323,10 @@
             <a:prstDash val="solid"/>
           </a:ln>
         </p:spPr>
+        <p:txBody>
+          <a:bodyPr/>
+          <a:p/>
+        </p:txBody>
       </p:sp>
       <p:sp>
         <p:nvSpPr>
@@ -10982,7 +11358,7 @@
                   <a:srgbClr val="6B7280"/>
                 </a:solidFill>
               </a:rPr>
-              <a:t>Cyclistic Bike-Share Analysis • Q1 2019 vs Q1 2020 • Based on final CSV provided</a:t>
+              <a:t>Cyclistic Bike-Share Analysis • Q1 2019 vs Q1 2020 • Divvy public trip data</a:t>
             </a:r>
             <a:endParaRPr lang="en-US" sz="650" dirty="0"/>
           </a:p>
@@ -11073,6 +11449,10 @@
             <a:prstDash val="solid"/>
           </a:ln>
         </p:spPr>
+        <p:txBody>
+          <a:bodyPr/>
+          <a:p/>
+        </p:txBody>
       </p:sp>
       <p:sp>
         <p:nvSpPr>
@@ -11246,6 +11626,10 @@
             <a:prstDash val="solid"/>
           </a:ln>
         </p:spPr>
+        <p:txBody>
+          <a:bodyPr/>
+          <a:p/>
+        </p:txBody>
       </p:sp>
       <p:sp>
         <p:nvSpPr>
@@ -11271,6 +11655,10 @@
             <a:prstDash val="solid"/>
           </a:ln>
         </p:spPr>
+        <p:txBody>
+          <a:bodyPr/>
+          <a:p/>
+        </p:txBody>
       </p:sp>
       <p:sp>
         <p:nvSpPr>
@@ -11334,6 +11722,10 @@
             <a:prstDash val="solid"/>
           </a:ln>
         </p:spPr>
+        <p:txBody>
+          <a:bodyPr/>
+          <a:p/>
+        </p:txBody>
       </p:sp>
       <p:sp>
         <p:nvSpPr>
@@ -11435,6 +11827,10 @@
             <a:prstDash val="solid"/>
           </a:ln>
         </p:spPr>
+        <p:txBody>
+          <a:bodyPr/>
+          <a:p/>
+        </p:txBody>
       </p:sp>
       <p:sp>
         <p:nvSpPr>
@@ -11498,6 +11894,10 @@
             <a:prstDash val="solid"/>
           </a:ln>
         </p:spPr>
+        <p:txBody>
+          <a:bodyPr/>
+          <a:p/>
+        </p:txBody>
       </p:sp>
       <p:sp>
         <p:nvSpPr>
@@ -11599,6 +11999,10 @@
             <a:prstDash val="solid"/>
           </a:ln>
         </p:spPr>
+        <p:txBody>
+          <a:bodyPr/>
+          <a:p/>
+        </p:txBody>
       </p:sp>
       <p:sp>
         <p:nvSpPr>
@@ -11662,6 +12066,10 @@
             <a:prstDash val="solid"/>
           </a:ln>
         </p:spPr>
+        <p:txBody>
+          <a:bodyPr/>
+          <a:p/>
+        </p:txBody>
       </p:sp>
       <p:sp>
         <p:nvSpPr>
@@ -11763,6 +12171,10 @@
             <a:prstDash val="solid"/>
           </a:ln>
         </p:spPr>
+        <p:txBody>
+          <a:bodyPr/>
+          <a:p/>
+        </p:txBody>
       </p:sp>
       <p:sp>
         <p:nvSpPr>
@@ -11826,6 +12238,10 @@
             <a:prstDash val="solid"/>
           </a:ln>
         </p:spPr>
+        <p:txBody>
+          <a:bodyPr/>
+          <a:p/>
+        </p:txBody>
       </p:sp>
       <p:sp>
         <p:nvSpPr>
@@ -11927,6 +12343,10 @@
             <a:prstDash val="solid"/>
           </a:ln>
         </p:spPr>
+        <p:txBody>
+          <a:bodyPr/>
+          <a:p/>
+        </p:txBody>
       </p:sp>
       <p:sp>
         <p:nvSpPr>
@@ -11990,6 +12410,10 @@
             <a:prstDash val="solid"/>
           </a:ln>
         </p:spPr>
+        <p:txBody>
+          <a:bodyPr/>
+          <a:p/>
+        </p:txBody>
       </p:sp>
       <p:sp>
         <p:nvSpPr>
@@ -12093,6 +12517,10 @@
             <a:prstDash val="solid"/>
           </a:ln>
         </p:spPr>
+        <p:txBody>
+          <a:bodyPr/>
+          <a:p/>
+        </p:txBody>
       </p:sp>
       <p:sp>
         <p:nvSpPr>
@@ -12192,6 +12620,10 @@
             <a:prstDash val="solid"/>
           </a:ln>
         </p:spPr>
+        <p:txBody>
+          <a:bodyPr/>
+          <a:p/>
+        </p:txBody>
       </p:sp>
       <p:sp>
         <p:nvSpPr>
@@ -12223,7 +12655,7 @@
                   <a:srgbClr val="6B7280"/>
                 </a:solidFill>
               </a:rPr>
-              <a:t>Cyclistic Bike-Share Analysis • Q1 2019 vs Q1 2020 • Based on final CSV provided</a:t>
+              <a:t>Cyclistic Bike-Share Analysis • Q1 2019 vs Q1 2020 • Divvy public trip data</a:t>
             </a:r>
             <a:endParaRPr lang="en-US" sz="650" dirty="0"/>
           </a:p>
@@ -12314,6 +12746,10 @@
             <a:prstDash val="solid"/>
           </a:ln>
         </p:spPr>
+        <p:txBody>
+          <a:bodyPr/>
+          <a:p/>
+        </p:txBody>
       </p:sp>
       <p:sp>
         <p:nvSpPr>
@@ -12491,10 +12927,14 @@
             <a:prstDash val="solid"/>
           </a:ln>
         </p:spPr>
+        <p:txBody>
+          <a:bodyPr/>
+          <a:p/>
+        </p:txBody>
       </p:sp>
       <p:pic>
         <p:nvPicPr>
-          <p:cNvPr id="8" name="Image 0" descr="/mnt/data/cyclistic_user_assets/ride_count_by_year_type.png">    </p:cNvPr>
+          <p:cNvPr id="8" name="Image 0" descr="ride_count_by_year_type">    </p:cNvPr>
           <p:cNvPicPr>
             <a:picLocks noChangeAspect="1"/>
           </p:cNvPicPr>
@@ -12542,6 +12982,10 @@
             <a:prstDash val="solid"/>
           </a:ln>
         </p:spPr>
+        <p:txBody>
+          <a:bodyPr/>
+          <a:p/>
+        </p:txBody>
       </p:sp>
       <p:sp>
         <p:nvSpPr>
@@ -12603,6 +13047,10 @@
             <a:prstDash val="solid"/>
           </a:ln>
         </p:spPr>
+        <p:txBody>
+          <a:bodyPr/>
+          <a:p/>
+        </p:txBody>
       </p:sp>
       <p:sp>
         <p:nvSpPr>
@@ -12666,6 +13114,10 @@
             <a:prstDash val="solid"/>
           </a:ln>
         </p:spPr>
+        <p:txBody>
+          <a:bodyPr/>
+          <a:p/>
+        </p:txBody>
       </p:sp>
       <p:sp>
         <p:nvSpPr>
@@ -12729,6 +13181,10 @@
             <a:prstDash val="solid"/>
           </a:ln>
         </p:spPr>
+        <p:txBody>
+          <a:bodyPr/>
+          <a:p/>
+        </p:txBody>
       </p:sp>
       <p:sp>
         <p:nvSpPr>
@@ -12792,6 +13248,10 @@
             <a:prstDash val="solid"/>
           </a:ln>
         </p:spPr>
+        <p:txBody>
+          <a:bodyPr/>
+          <a:p/>
+        </p:txBody>
       </p:sp>
       <p:sp>
         <p:nvSpPr>
@@ -12929,6 +13389,10 @@
             <a:prstDash val="solid"/>
           </a:ln>
         </p:spPr>
+        <p:txBody>
+          <a:bodyPr/>
+          <a:p/>
+        </p:txBody>
       </p:sp>
       <p:sp>
         <p:nvSpPr>
@@ -12960,7 +13424,7 @@
                   <a:srgbClr val="6B7280"/>
                 </a:solidFill>
               </a:rPr>
-              <a:t>Cyclistic Bike-Share Analysis • Q1 2019 vs Q1 2020 • Based on final CSV provided</a:t>
+              <a:t>Cyclistic Bike-Share Analysis • Q1 2019 vs Q1 2020 • Divvy public trip data</a:t>
             </a:r>
             <a:endParaRPr lang="en-US" sz="650" dirty="0"/>
           </a:p>
@@ -13051,6 +13515,10 @@
             <a:prstDash val="solid"/>
           </a:ln>
         </p:spPr>
+        <p:txBody>
+          <a:bodyPr/>
+          <a:p/>
+        </p:txBody>
       </p:sp>
       <p:sp>
         <p:nvSpPr>
@@ -13196,7 +13664,7 @@
                   <a:srgbClr val="6B7280"/>
                 </a:solidFill>
               </a:rPr>
-              <a:t>The average ride length is higher for casual riders in both years; the median confirms the same directional pattern.</a:t>
+              <a:t>Casual riders ride longer in both years. Medians are the safer comparison because a few very long casual trips pull the averages up.</a:t>
             </a:r>
             <a:endParaRPr lang="en-US" sz="950" dirty="0"/>
           </a:p>
@@ -13228,10 +13696,14 @@
             <a:prstDash val="solid"/>
           </a:ln>
         </p:spPr>
+        <p:txBody>
+          <a:bodyPr/>
+          <a:p/>
+        </p:txBody>
       </p:sp>
       <p:pic>
         <p:nvPicPr>
-          <p:cNvPr id="8" name="Image 0" descr="/mnt/data/cyclistic_user_assets/avg_duration_by_year_type.png">    </p:cNvPr>
+          <p:cNvPr id="8" name="Image 0" descr="avg_duration_by_year_type">    </p:cNvPr>
           <p:cNvPicPr>
             <a:picLocks noChangeAspect="1"/>
           </p:cNvPicPr>
@@ -13279,6 +13751,10 @@
             <a:prstDash val="solid"/>
           </a:ln>
         </p:spPr>
+        <p:txBody>
+          <a:bodyPr/>
+          <a:p/>
+        </p:txBody>
       </p:sp>
       <p:sp>
         <p:nvSpPr>
@@ -13419,6 +13895,10 @@
             <a:prstDash val="solid"/>
           </a:ln>
         </p:spPr>
+        <p:txBody>
+          <a:bodyPr/>
+          <a:p/>
+        </p:txBody>
       </p:sp>
       <p:sp>
         <p:nvSpPr>
@@ -13559,6 +14039,10 @@
             <a:prstDash val="solid"/>
           </a:ln>
         </p:spPr>
+        <p:txBody>
+          <a:bodyPr/>
+          <a:p/>
+        </p:txBody>
       </p:sp>
       <p:sp>
         <p:nvSpPr>
@@ -13590,7 +14074,7 @@
                   <a:srgbClr val="0B3154"/>
                 </a:solidFill>
               </a:rPr>
-              <a:t>Specific values from the supplied CSV</a:t>
+              <a:t>Values by year</a:t>
             </a:r>
             <a:endParaRPr lang="en-US" sz="1350" dirty="0"/>
           </a:p>
@@ -13620,6 +14104,10 @@
             <a:prstDash val="solid"/>
           </a:ln>
         </p:spPr>
+        <p:txBody>
+          <a:bodyPr/>
+          <a:p/>
+        </p:txBody>
       </p:sp>
       <p:sp>
         <p:nvSpPr>
@@ -13683,6 +14171,10 @@
             <a:prstDash val="solid"/>
           </a:ln>
         </p:spPr>
+        <p:txBody>
+          <a:bodyPr/>
+          <a:p/>
+        </p:txBody>
       </p:sp>
       <p:sp>
         <p:nvSpPr>
@@ -13746,6 +14238,10 @@
             <a:prstDash val="solid"/>
           </a:ln>
         </p:spPr>
+        <p:txBody>
+          <a:bodyPr/>
+          <a:p/>
+        </p:txBody>
       </p:sp>
       <p:sp>
         <p:nvSpPr>
@@ -13817,7 +14313,7 @@
                   <a:srgbClr val="6B7280"/>
                 </a:solidFill>
               </a:rPr>
-              <a:t>Note: These figures use the final CSV exactly as provided. They match the Tableau dashboard values.</a:t>
+              <a:t>Note: the 2020 casual average is inflated by outliers (casual rides starting at 4 AM average over 20 hours). Medians: casual 23.4 / 21.2 min, member 8.4 / 8.6 min (2019 / 2020).</a:t>
             </a:r>
             <a:endParaRPr lang="en-US" sz="760" dirty="0"/>
           </a:p>
@@ -13847,6 +14343,10 @@
             <a:prstDash val="solid"/>
           </a:ln>
         </p:spPr>
+        <p:txBody>
+          <a:bodyPr/>
+          <a:p/>
+        </p:txBody>
       </p:sp>
       <p:sp>
         <p:nvSpPr>
@@ -13878,7 +14378,7 @@
                   <a:srgbClr val="6B7280"/>
                 </a:solidFill>
               </a:rPr>
-              <a:t>Cyclistic Bike-Share Analysis • Q1 2019 vs Q1 2020 • Based on final CSV provided</a:t>
+              <a:t>Cyclistic Bike-Share Analysis • Q1 2019 vs Q1 2020 • Divvy public trip data</a:t>
             </a:r>
             <a:endParaRPr lang="en-US" sz="650" dirty="0"/>
           </a:p>
@@ -13969,6 +14469,10 @@
             <a:prstDash val="solid"/>
           </a:ln>
         </p:spPr>
+        <p:txBody>
+          <a:bodyPr/>
+          <a:p/>
+        </p:txBody>
       </p:sp>
       <p:sp>
         <p:nvSpPr>
@@ -14146,10 +14650,14 @@
             <a:prstDash val="solid"/>
           </a:ln>
         </p:spPr>
+        <p:txBody>
+          <a:bodyPr/>
+          <a:p/>
+        </p:txBody>
       </p:sp>
       <p:pic>
         <p:nvPicPr>
-          <p:cNvPr id="8" name="Image 0" descr="/mnt/data/cyclistic_user_assets/weekday_share_by_type.png">    </p:cNvPr>
+          <p:cNvPr id="8" name="Image 0" descr="weekday_share_by_type">    </p:cNvPr>
           <p:cNvPicPr>
             <a:picLocks noChangeAspect="1"/>
           </p:cNvPicPr>
@@ -14197,6 +14705,10 @@
             <a:prstDash val="solid"/>
           </a:ln>
         </p:spPr>
+        <p:txBody>
+          <a:bodyPr/>
+          <a:p/>
+        </p:txBody>
       </p:sp>
       <p:sp>
         <p:nvSpPr>
@@ -14260,6 +14772,10 @@
             <a:prstDash val="solid"/>
           </a:ln>
         </p:spPr>
+        <p:txBody>
+          <a:bodyPr/>
+          <a:p/>
+        </p:txBody>
       </p:sp>
       <p:sp>
         <p:nvSpPr>
@@ -14400,6 +14916,10 @@
             <a:prstDash val="solid"/>
           </a:ln>
         </p:spPr>
+        <p:txBody>
+          <a:bodyPr/>
+          <a:p/>
+        </p:txBody>
       </p:sp>
       <p:sp>
         <p:nvSpPr>
@@ -14540,6 +15060,10 @@
             <a:prstDash val="solid"/>
           </a:ln>
         </p:spPr>
+        <p:txBody>
+          <a:bodyPr/>
+          <a:p/>
+        </p:txBody>
       </p:sp>
       <p:sp>
         <p:nvSpPr>
@@ -14680,6 +15204,10 @@
             <a:prstDash val="solid"/>
           </a:ln>
         </p:spPr>
+        <p:txBody>
+          <a:bodyPr/>
+          <a:p/>
+        </p:txBody>
       </p:sp>
       <p:sp>
         <p:nvSpPr>
@@ -14892,6 +15420,10 @@
             <a:prstDash val="solid"/>
           </a:ln>
         </p:spPr>
+        <p:txBody>
+          <a:bodyPr/>
+          <a:p/>
+        </p:txBody>
       </p:sp>
       <p:sp>
         <p:nvSpPr>
@@ -14923,7 +15455,7 @@
                   <a:srgbClr val="6B7280"/>
                 </a:solidFill>
               </a:rPr>
-              <a:t>Cyclistic Bike-Share Analysis • Q1 2019 vs Q1 2020 • Based on final CSV provided</a:t>
+              <a:t>Cyclistic Bike-Share Analysis • Q1 2019 vs Q1 2020 • Divvy public trip data</a:t>
             </a:r>
             <a:endParaRPr lang="en-US" sz="650" dirty="0"/>
           </a:p>
@@ -15014,6 +15546,10 @@
             <a:prstDash val="solid"/>
           </a:ln>
         </p:spPr>
+        <p:txBody>
+          <a:bodyPr/>
+          <a:p/>
+        </p:txBody>
       </p:sp>
       <p:sp>
         <p:nvSpPr>
@@ -15191,10 +15727,14 @@
             <a:prstDash val="solid"/>
           </a:ln>
         </p:spPr>
+        <p:txBody>
+          <a:bodyPr/>
+          <a:p/>
+        </p:txBody>
       </p:sp>
       <p:pic>
         <p:nvPicPr>
-          <p:cNvPr id="8" name="Image 0" descr="/mnt/data/cyclistic_user_assets/hourly_pattern_by_type.png">    </p:cNvPr>
+          <p:cNvPr id="8" name="Image 0" descr="hourly_pattern_by_type">    </p:cNvPr>
           <p:cNvPicPr>
             <a:picLocks noChangeAspect="1"/>
           </p:cNvPicPr>
@@ -15242,6 +15782,10 @@
             <a:prstDash val="solid"/>
           </a:ln>
         </p:spPr>
+        <p:txBody>
+          <a:bodyPr/>
+          <a:p/>
+        </p:txBody>
       </p:sp>
       <p:sp>
         <p:nvSpPr>
@@ -15273,7 +15817,7 @@
                   <a:srgbClr val="0B3154"/>
                 </a:solidFill>
               </a:rPr>
-              <a:t>Peak usage from the CSV</a:t>
+              <a:t>Peak start hour (both years combined)</a:t>
             </a:r>
             <a:endParaRPr lang="en-US" sz="1600" dirty="0"/>
           </a:p>
@@ -15305,6 +15849,10 @@
             <a:prstDash val="solid"/>
           </a:ln>
         </p:spPr>
+        <p:txBody>
+          <a:bodyPr/>
+          <a:p/>
+        </p:txBody>
       </p:sp>
       <p:sp>
         <p:nvSpPr>
@@ -15445,6 +15993,10 @@
             <a:prstDash val="solid"/>
           </a:ln>
         </p:spPr>
+        <p:txBody>
+          <a:bodyPr/>
+          <a:p/>
+        </p:txBody>
       </p:sp>
       <p:sp>
         <p:nvSpPr>
@@ -15583,6 +16135,10 @@
             <a:prstDash val="solid"/>
           </a:ln>
         </p:spPr>
+        <p:txBody>
+          <a:bodyPr/>
+          <a:p/>
+        </p:txBody>
       </p:sp>
       <p:sp>
         <p:nvSpPr>
@@ -15646,6 +16202,10 @@
             <a:prstDash val="solid"/>
           </a:ln>
         </p:spPr>
+        <p:txBody>
+          <a:bodyPr/>
+          <a:p/>
+        </p:txBody>
       </p:sp>
       <p:sp>
         <p:nvSpPr>
@@ -15709,6 +16269,10 @@
             <a:prstDash val="solid"/>
           </a:ln>
         </p:spPr>
+        <p:txBody>
+          <a:bodyPr/>
+          <a:p/>
+        </p:txBody>
       </p:sp>
       <p:sp>
         <p:nvSpPr>
@@ -15772,6 +16336,10 @@
             <a:prstDash val="solid"/>
           </a:ln>
         </p:spPr>
+        <p:txBody>
+          <a:bodyPr/>
+          <a:p/>
+        </p:txBody>
       </p:sp>
       <p:sp>
         <p:nvSpPr>
@@ -15803,7 +16371,7 @@
                   <a:srgbClr val="6B7280"/>
                 </a:solidFill>
               </a:rPr>
-              <a:t>Cyclistic Bike-Share Analysis • Q1 2019 vs Q1 2020 • Based on final CSV provided</a:t>
+              <a:t>Cyclistic Bike-Share Analysis • Q1 2019 vs Q1 2020 • Divvy public trip data</a:t>
             </a:r>
             <a:endParaRPr lang="en-US" sz="650" dirty="0"/>
           </a:p>

</xml_diff>